<commit_message>
200k-episode headline run, refreshed deck and docs, configurable run sizes, fastapi and uvicorn in requirements
</commit_message>
<xml_diff>
--- a/deck/ARTS_walkthrough.pptx
+++ b/deck/ARTS_walkthrough.pptx
@@ -202,7 +202,7 @@
                     <c:v>Allowlist aliasing</c:v>
                   </c:pt>
                   <c:pt idx="6">
-                    <c:v>Agentic ATO</c:v>
+                    <c:v>Memory poisoning</c:v>
                   </c:pt>
                   <c:pt idx="7">
                     <c:v>Mule network</c:v>
@@ -233,10 +233,10 @@
                   <c:v>0</c:v>
                 </c:pt>
                 <c:pt idx="5">
-                  <c:v>0.5</c:v>
+                  <c:v>0</c:v>
                 </c:pt>
                 <c:pt idx="6">
-                  <c:v>0.25</c:v>
+                  <c:v>0</c:v>
                 </c:pt>
                 <c:pt idx="7">
                   <c:v>1</c:v>
@@ -315,7 +315,7 @@
                     <c:v>Allowlist aliasing</c:v>
                   </c:pt>
                   <c:pt idx="6">
-                    <c:v>Agentic ATO</c:v>
+                    <c:v>Memory poisoning</c:v>
                   </c:pt>
                   <c:pt idx="7">
                     <c:v>Mule network</c:v>
@@ -340,16 +340,16 @@
                   <c:v>1</c:v>
                 </c:pt>
                 <c:pt idx="3">
-                  <c:v>1</c:v>
+                  <c:v>0.9926</c:v>
                 </c:pt>
                 <c:pt idx="4">
-                  <c:v>0.7143</c:v>
+                  <c:v>0.6176</c:v>
                 </c:pt>
                 <c:pt idx="5">
-                  <c:v>0.6875</c:v>
+                  <c:v>0.6562</c:v>
                 </c:pt>
                 <c:pt idx="6">
-                  <c:v>1</c:v>
+                  <c:v>0.9688</c:v>
                 </c:pt>
                 <c:pt idx="7">
                   <c:v>0</c:v>
@@ -615,19 +615,19 @@
                 <c:formatCode>General</c:formatCode>
                 <c:ptCount val="5"/>
                 <c:pt idx="0">
-                  <c:v>0.7656</c:v>
+                  <c:v>0.877</c:v>
                 </c:pt>
                 <c:pt idx="1">
-                  <c:v>0.8735</c:v>
+                  <c:v>0.8984</c:v>
                 </c:pt>
                 <c:pt idx="2">
-                  <c:v>0.9805</c:v>
+                  <c:v>0.9595</c:v>
                 </c:pt>
                 <c:pt idx="3">
-                  <c:v>0.73</c:v>
+                  <c:v>0.7115</c:v>
                 </c:pt>
                 <c:pt idx="4">
-                  <c:v>0.9835</c:v>
+                  <c:v>0.9633</c:v>
                 </c:pt>
               </c:numCache>
             </c:numRef>
@@ -715,19 +715,19 @@
                 <c:formatCode>General</c:formatCode>
                 <c:ptCount val="5"/>
                 <c:pt idx="0">
-                  <c:v>0.344</c:v>
+                  <c:v>0.1236</c:v>
                 </c:pt>
                 <c:pt idx="1">
-                  <c:v>0.3085</c:v>
+                  <c:v>0.4583</c:v>
                 </c:pt>
                 <c:pt idx="2">
-                  <c:v>0.4965</c:v>
+                  <c:v>0.6039</c:v>
                 </c:pt>
                 <c:pt idx="3">
-                  <c:v>0.461</c:v>
+                  <c:v>0.4239</c:v>
                 </c:pt>
                 <c:pt idx="4">
-                  <c:v>0.6277</c:v>
+                  <c:v>0.7133</c:v>
                 </c:pt>
               </c:numCache>
             </c:numRef>
@@ -6105,7 +6105,7 @@
                 <a:ea typeface="Calibri" pitchFamily="34" charset="-122"/>
                 <a:cs typeface="Calibri" pitchFamily="34" charset="-120"/>
               </a:rPr>
-              <a:t>Between 4 and 58 test records per attack. Arm-level numbers are well powered; the per-vector table is directional.</a:t>
+              <a:t>Between 26 and 406 test records per attack after the 200,000 episode run. Adequate for the arm-level claims, thin for the smallest vectors.</a:t>
             </a:r>
             <a:endParaRPr lang="en-US" sz="1250" dirty="0"/>
           </a:p>
@@ -6213,7 +6213,7 @@
                 <a:ea typeface="Calibri" pitchFamily="34" charset="-122"/>
                 <a:cs typeface="Calibri" pitchFamily="34" charset="-120"/>
               </a:rPr>
-              <a:t>Arm E reaches 0.9996 with agentic attacks in training. Real fraud is less separable than simulated fraud, even with perfect labels.</a:t>
+              <a:t>Arm E reaches 1.000 with agentic attacks in training. Real fraud is less separable than simulated fraud, even with perfect labels.</a:t>
             </a:r>
             <a:endParaRPr lang="en-US" sz="1250" dirty="0"/>
           </a:p>
@@ -6562,7 +6562,7 @@
                 <a:ea typeface="Cambria" pitchFamily="34" charset="-122"/>
                 <a:cs typeface="Cambria" pitchFamily="34" charset="-120"/>
               </a:rPr>
-              <a:t>found our own detector blind to a third, and shipped a defense</a:t>
+              <a:t>found our own detector blind to eighteen of them, and shipped a defense</a:t>
             </a:r>
             <a:endParaRPr lang="en-US" sz="2800" dirty="0"/>
           </a:p>
@@ -6777,7 +6777,7 @@
                 <a:ea typeface="Cambria" pitchFamily="34" charset="-122"/>
                 <a:cs typeface="Cambria" pitchFamily="34" charset="-120"/>
               </a:rPr>
-              <a:t>0.984</a:t>
+              <a:t>0.963</a:t>
             </a:r>
             <a:endParaRPr lang="en-US" sz="3600" dirty="0"/>
           </a:p>
@@ -6855,7 +6855,7 @@
                 <a:ea typeface="Cambria" pitchFamily="34" charset="-122"/>
                 <a:cs typeface="Cambria" pitchFamily="34" charset="-120"/>
               </a:rPr>
-              <a:t>0.7%</a:t>
+              <a:t>0.5%</a:t>
             </a:r>
             <a:endParaRPr lang="en-US" sz="3600" dirty="0"/>
           </a:p>
@@ -11706,7 +11706,7 @@
                 <a:ea typeface="Calibri" pitchFamily="34" charset="-122"/>
                 <a:cs typeface="Calibri" pitchFamily="34" charset="-120"/>
               </a:rPr>
-              <a:t>Five agentic vectors sit at exactly 0.00 for the incumbent. These are the attacks the taxonomy predicted would be invisible at the network, and they are.</a:t>
+              <a:t>Eighteen of twenty-one agentic vectors sit at exactly 0.00 for the incumbent. These are the attacks the taxonomy predicted would be invisible at the network, and they are.</a:t>
             </a:r>
             <a:endParaRPr lang="en-US" sz="1200" dirty="0"/>
           </a:p>
@@ -12565,7 +12565,7 @@
                 <a:ea typeface="Cambria" pitchFamily="34" charset="-122"/>
                 <a:cs typeface="Cambria" pitchFamily="34" charset="-120"/>
               </a:rPr>
-              <a:t>0.984</a:t>
+              <a:t>0.963</a:t>
             </a:r>
             <a:endParaRPr lang="en-US" sz="4400" dirty="0"/>
           </a:p>
@@ -12607,7 +12607,7 @@
                 <a:ea typeface="Calibri" pitchFamily="34" charset="-122"/>
                 <a:cs typeface="Calibri" pitchFamily="34" charset="-120"/>
               </a:rPr>
-              <a:t>AUC on unseen agentic attacks, at a 0.7% alert rate</a:t>
+              <a:t>AUC on unseen agentic attacks, at a 0.5% alert rate</a:t>
             </a:r>
             <a:endParaRPr lang="en-US" sz="1200" dirty="0"/>
           </a:p>

</xml_diff>